<commit_message>
L10 + L17: tap-to-mark for bilugan/ekis/check/guhitan in participant guides; notes say ipa-tap
Co-Authored-By: Claude Opus 5.5 <noreply@anthropic.com>
Claude-Session: https://claude.ai/code/session_01DJ4qKnLB4Yge6pvZD9iFVz
</commit_message>
<xml_diff>
--- a/lessons/btli101_xrw5fg/btli1_l10_slides.pptx
+++ b/lessons/btli101_xrw5fg/btli1_l10_slides.pptx
@@ -1531,7 +1531,7 @@
           <a:p>
             <a:r>
               <a:rPr lang="en-US" dirty="0"/>
-              <a:t>Ipaguhitan sa guide ang dahilan kung bakit ginawa ni Jesus ang Kaniyang ginawa: binigyan ko kayo ng halimbawa upang inyong tularan.</a:t>
+              <a:t>Sa guide, ipa-tap para guhitan ang dahilan kung bakit ginawa ni Jesus ang Kaniyang ginawa: binigyan ko kayo ng halimbawa upang inyong tularan (sa printed guide, guhitan ng pen).</a:t>
             </a:r>
             <a:endParaRPr lang="en-US" dirty="0"/>
           </a:p>
@@ -1985,7 +1985,7 @@
           <a:p>
             <a:r>
               <a:rPr lang="en-US" dirty="0"/>
-              <a:t>Ipabilog sa guide ang dalawang dahilan ni Jesus sa pagparito sa mundo: maglingkod, at mag-alay ng buhay.</a:t>
+              <a:t>Sa ikaapat na dahilan mamaya, ita-tap nila sa guide ang dalawang dahilan ni Jesus sa pagparito para bilugan: maglingkod, at mag-alay ng buhay (sa printed guide, bilugan ng pen).</a:t>
             </a:r>
           </a:p>
           <a:p>
@@ -4385,7 +4385,7 @@
           <a:p>
             <a:r>
               <a:rPr lang="en-US" dirty="0"/>
-              <a:t>Ipalagay sa guide: ekis sa salitang tamad, check sa magpakasipag at maglingkod.</a:t>
+              <a:t>Sa guide, ipa-tap ang mga salita: ang tamad para malagyan ng ekis, ang magpakasipag at maglingkod para ma-check (sa printed guide, gamitin ang pen).</a:t>
             </a:r>
           </a:p>
           <a:p>

</xml_diff>

<commit_message>
L10 + L17: tap-to-mark for bilugan/ekis/check/guhitan in participant guides; notes say ipa-tap (#348)
Claude-Session: https://claude.ai/code/session_01DJ4qKnLB4Yge6pvZD9iFVz

Co-authored-by: Claude <noreply@anthropic.com>
</commit_message>
<xml_diff>
--- a/lessons/btli101_xrw5fg/btli1_l10_slides.pptx
+++ b/lessons/btli101_xrw5fg/btli1_l10_slides.pptx
@@ -1531,7 +1531,7 @@
           <a:p>
             <a:r>
               <a:rPr lang="en-US" dirty="0"/>
-              <a:t>Ipaguhitan sa guide ang dahilan kung bakit ginawa ni Jesus ang Kaniyang ginawa: binigyan ko kayo ng halimbawa upang inyong tularan.</a:t>
+              <a:t>Sa guide, ipa-tap para guhitan ang dahilan kung bakit ginawa ni Jesus ang Kaniyang ginawa: binigyan ko kayo ng halimbawa upang inyong tularan (sa printed guide, guhitan ng pen).</a:t>
             </a:r>
             <a:endParaRPr lang="en-US" dirty="0"/>
           </a:p>
@@ -1985,7 +1985,7 @@
           <a:p>
             <a:r>
               <a:rPr lang="en-US" dirty="0"/>
-              <a:t>Ipabilog sa guide ang dalawang dahilan ni Jesus sa pagparito sa mundo: maglingkod, at mag-alay ng buhay.</a:t>
+              <a:t>Sa ikaapat na dahilan mamaya, ita-tap nila sa guide ang dalawang dahilan ni Jesus sa pagparito para bilugan: maglingkod, at mag-alay ng buhay (sa printed guide, bilugan ng pen).</a:t>
             </a:r>
           </a:p>
           <a:p>
@@ -4385,7 +4385,7 @@
           <a:p>
             <a:r>
               <a:rPr lang="en-US" dirty="0"/>
-              <a:t>Ipalagay sa guide: ekis sa salitang tamad, check sa magpakasipag at maglingkod.</a:t>
+              <a:t>Sa guide, ipa-tap ang mga salita: ang tamad para malagyan ng ekis, ang magpakasipag at maglingkod para ma-check (sa printed guide, gamitin ang pen).</a:t>
             </a:r>
           </a:p>
           <a:p>

</xml_diff>

<commit_message>
L10 deck: restore ipa-tap wording on slides 9 and 16 notes (keeps Pastor's revised deck)
Co-Authored-By: Claude Opus 5.5 <noreply@anthropic.com>
Claude-Session: https://claude.ai/code/session_01DJ4qKnLB4Yge6pvZD9iFVz
</commit_message>
<xml_diff>
--- a/lessons/btli101_xrw5fg/btli1_l10_slides.pptx
+++ b/lessons/btli101_xrw5fg/btli1_l10_slides.pptx
@@ -1392,11 +1392,11 @@
           <a:p>
             <a:r>
               <a:rPr lang="en-US" b="1" dirty="0"/>
-              <a:t>Ipaguhitan sa guide</a:t>
-            </a:r>
-            <a:r>
-              <a:rPr lang="en-US" dirty="0"/>
-              <a:t> ang dahilan kung bakit ginawa ni Jesus ang Kaniyang ginawa: binigyan ko kayo ng halimbawa upang inyong tularan.</a:t>
+              <a:t>Ipa-tap sa guide para guhitan</a:t>
+            </a:r>
+            <a:r>
+              <a:rPr lang="en-US" dirty="0"/>
+              <a:t> ang dahilan kung bakit ginawa ni Jesus ang Kaniyang ginawa: binigyan ko kayo ng halimbawa upang inyong tularan (sa printed guide, guhitan ng pen).</a:t>
             </a:r>
           </a:p>
         </p:txBody>
@@ -4580,11 +4580,11 @@
           <a:p>
             <a:r>
               <a:rPr lang="en-US" b="1" dirty="0"/>
-              <a:t>Ipalagay sa guide: </a:t>
-            </a:r>
-            <a:r>
-              <a:rPr lang="en-US" dirty="0"/>
-              <a:t>ekis sa salitang tamad, check sa magpakasipag at maglingkod.</a:t>
+              <a:t>Ipa-tap sa guide: </a:t>
+            </a:r>
+            <a:r>
+              <a:rPr lang="en-US" dirty="0"/>
+              <a:t>ekis sa salitang tamad, check sa magpakasipag at maglingkod (sa printed guide, gamitin ang pen).</a:t>
             </a:r>
           </a:p>
           <a:p>

</xml_diff>